<commit_message>
Update final report and slides with correct architecture, author, and features
</commit_message>
<xml_diff>
--- a/CitationTrace_Slides.pptx
+++ b/CitationTrace_Slides.pptx
@@ -3967,6 +3967,10 @@
           </a:solidFill>
           <a:ln/>
         </p:spPr>
+        <p:txBody>
+          <a:bodyPr/>
+          <a:p/>
+        </p:txBody>
       </p:sp>
       <p:sp>
         <p:nvSpPr>
@@ -4035,6 +4039,10 @@
             </a:outerShdw>
           </a:effectLst>
         </p:spPr>
+        <p:txBody>
+          <a:bodyPr/>
+          <a:p/>
+        </p:txBody>
       </p:sp>
       <p:sp>
         <p:nvSpPr>
@@ -4227,6 +4235,10 @@
             </a:outerShdw>
           </a:effectLst>
         </p:spPr>
+        <p:txBody>
+          <a:bodyPr/>
+          <a:p/>
+        </p:txBody>
       </p:sp>
       <p:sp>
         <p:nvSpPr>
@@ -4338,7 +4350,7 @@
                 <a:ea typeface="Calibri" pitchFamily="34" charset="-122"/>
                 <a:cs typeface="Calibri" pitchFamily="34" charset="-120"/>
               </a:rPr>
-              <a:t>Cosine similarity threshold ≥ 0.35</a:t>
+              <a:t>NLI 4-class threshold (Supported ≥ 0.70)</a:t>
             </a:r>
             <a:endParaRPr lang="en-US" sz="1600" dirty="0"/>
           </a:p>
@@ -7247,6 +7259,10 @@
           </a:solidFill>
           <a:ln/>
         </p:spPr>
+        <p:txBody>
+          <a:bodyPr/>
+          <a:p/>
+        </p:txBody>
       </p:sp>
       <p:sp>
         <p:nvSpPr>
@@ -7267,6 +7283,10 @@
           </a:solidFill>
           <a:ln/>
         </p:spPr>
+        <p:txBody>
+          <a:bodyPr/>
+          <a:p/>
+        </p:txBody>
       </p:sp>
       <p:sp>
         <p:nvSpPr>
@@ -7340,7 +7360,7 @@
                 <a:ea typeface="Calibri" pitchFamily="34" charset="-122"/>
                 <a:cs typeface="Calibri" pitchFamily="34" charset="-120"/>
               </a:rPr>
-              <a:t>RAG pipeline over real academic databases (Semantic Scholar, 45M+ papers)</a:t>
+              <a:t>RAG pipeline over 3 scholarly APIs in parallel: OpenAlex (250M+), CrossRef (140M+), PubMed (37M+)</a:t>
             </a:r>
             <a:endParaRPr lang="en-US" sz="1400" dirty="0"/>
           </a:p>
@@ -7367,6 +7387,10 @@
           </a:solidFill>
           <a:ln/>
         </p:spPr>
+        <p:txBody>
+          <a:bodyPr/>
+          <a:p/>
+        </p:txBody>
       </p:sp>
       <p:sp>
         <p:nvSpPr>
@@ -7387,6 +7411,10 @@
           </a:solidFill>
           <a:ln/>
         </p:spPr>
+        <p:txBody>
+          <a:bodyPr/>
+          <a:p/>
+        </p:txBody>
       </p:sp>
       <p:sp>
         <p:nvSpPr>
@@ -7487,6 +7515,10 @@
           </a:solidFill>
           <a:ln/>
         </p:spPr>
+        <p:txBody>
+          <a:bodyPr/>
+          <a:p/>
+        </p:txBody>
       </p:sp>
       <p:sp>
         <p:nvSpPr>
@@ -7507,6 +7539,10 @@
           </a:solidFill>
           <a:ln/>
         </p:spPr>
+        <p:txBody>
+          <a:bodyPr/>
+          <a:p/>
+        </p:txBody>
       </p:sp>
       <p:sp>
         <p:nvSpPr>
@@ -7637,6 +7673,10 @@
           </a:solidFill>
           <a:ln/>
         </p:spPr>
+        <p:txBody>
+          <a:bodyPr/>
+          <a:p/>
+        </p:txBody>
       </p:sp>
       <p:sp>
         <p:nvSpPr>
@@ -7698,6 +7738,10 @@
           </a:solidFill>
           <a:ln/>
         </p:spPr>
+        <p:txBody>
+          <a:bodyPr/>
+          <a:p/>
+        </p:txBody>
       </p:sp>
       <p:sp>
         <p:nvSpPr>
@@ -7759,6 +7803,10 @@
           </a:solidFill>
           <a:ln/>
         </p:spPr>
+        <p:txBody>
+          <a:bodyPr/>
+          <a:p/>
+        </p:txBody>
       </p:sp>
       <p:sp>
         <p:nvSpPr>
@@ -7837,6 +7885,10 @@
           </a:solidFill>
           <a:ln/>
         </p:spPr>
+        <p:txBody>
+          <a:bodyPr/>
+          <a:p/>
+        </p:txBody>
       </p:sp>
       <p:sp>
         <p:nvSpPr>
@@ -7862,6 +7914,7 @@
             <a:pPr algn="ctr" indent="0" marL="0">
               <a:buNone/>
             </a:pPr>
+            <a:endParaRPr lang="en-US" sz="1100" dirty="0"/>
             <a:r>
               <a:rPr lang="en-US" sz="1100" b="1" dirty="0">
                 <a:solidFill>
@@ -7871,14 +7924,31 @@
                 <a:ea typeface="Calibri" pitchFamily="34" charset="-122"/>
                 <a:cs typeface="Calibri" pitchFamily="34" charset="-120"/>
               </a:rPr>
-              <a:t>Semantic</a:t>
-            </a:r>
+              <a:t>OpenAlex +</a:t>
+            </a:r>
+          </a:p>
+          <a:p>
+            <a:pPr algn="ctr" indent="0" marL="0">
+              <a:buNone/>
+            </a:pPr>
             <a:endParaRPr lang="en-US" sz="1100" dirty="0"/>
+            <a:r>
+              <a:rPr lang="en-US" sz="1100" b="1" dirty="0">
+                <a:solidFill>
+                  <a:srgbClr val="FFFFFF"/>
+                </a:solidFill>
+                <a:latin typeface="Calibri" pitchFamily="34" charset="0"/>
+                <a:ea typeface="Calibri" pitchFamily="34" charset="-122"/>
+                <a:cs typeface="Calibri" pitchFamily="34" charset="-120"/>
+              </a:rPr>
+              <a:t>CrossRef +</a:t>
+            </a:r>
           </a:p>
           <a:p>
             <a:pPr algn="ctr" indent="0" marL="0">
               <a:buNone/>
             </a:pPr>
+            <a:endParaRPr lang="en-US" sz="1100" dirty="0"/>
             <a:r>
               <a:rPr lang="en-US" sz="1100" b="1" dirty="0">
                 <a:solidFill>
@@ -7888,9 +7958,8 @@
                 <a:ea typeface="Calibri" pitchFamily="34" charset="-122"/>
                 <a:cs typeface="Calibri" pitchFamily="34" charset="-120"/>
               </a:rPr>
-              <a:t>Scholar API</a:t>
-            </a:r>
-            <a:endParaRPr lang="en-US" sz="1100" dirty="0"/>
+              <a:t>PubMed</a:t>
+            </a:r>
           </a:p>
         </p:txBody>
       </p:sp>
@@ -7915,6 +7984,10 @@
           </a:solidFill>
           <a:ln/>
         </p:spPr>
+        <p:txBody>
+          <a:bodyPr/>
+          <a:p/>
+        </p:txBody>
       </p:sp>
       <p:sp>
         <p:nvSpPr>
@@ -7993,6 +8066,10 @@
           </a:solidFill>
           <a:ln/>
         </p:spPr>
+        <p:txBody>
+          <a:bodyPr/>
+          <a:p/>
+        </p:txBody>
       </p:sp>
       <p:sp>
         <p:nvSpPr>
@@ -8071,6 +8148,10 @@
           </a:solidFill>
           <a:ln/>
         </p:spPr>
+        <p:txBody>
+          <a:bodyPr/>
+          <a:p/>
+        </p:txBody>
       </p:sp>
       <p:sp>
         <p:nvSpPr>
@@ -8342,6 +8423,10 @@
           </a:solidFill>
           <a:ln/>
         </p:spPr>
+        <p:txBody>
+          <a:bodyPr/>
+          <a:p/>
+        </p:txBody>
       </p:sp>
       <p:sp>
         <p:nvSpPr>
@@ -8418,6 +8503,10 @@
           </a:solidFill>
           <a:ln/>
         </p:spPr>
+        <p:txBody>
+          <a:bodyPr/>
+          <a:p/>
+        </p:txBody>
       </p:sp>
       <p:sp>
         <p:nvSpPr>
@@ -8610,7 +8699,7 @@
                 <a:ea typeface="Calibri" pitchFamily="34" charset="-122"/>
                 <a:cs typeface="Calibri" pitchFamily="34" charset="-120"/>
               </a:rPr>
-              <a:t>Semantic Scholar API: Access to 45M+ academic papers</a:t>
+              <a:t>OpenAlex + CrossRef + PubMed: 420M+ papers across 3 parallel sources</a:t>
             </a:r>
             <a:endParaRPr lang="en-US" sz="1400" dirty="0"/>
           </a:p>
@@ -8631,7 +8720,7 @@
                 <a:ea typeface="Calibri" pitchFamily="34" charset="-122"/>
                 <a:cs typeface="Calibri" pitchFamily="34" charset="-120"/>
               </a:rPr>
-              <a:t>RAG Retriever/Reranker: Relevance-scored document retrieval</a:t>
+              <a:t>BM25 Reranker: Relevance × citation count scoring (top 20 from 30 candidates)</a:t>
             </a:r>
             <a:endParaRPr lang="en-US" sz="1400" dirty="0"/>
           </a:p>
@@ -8727,6 +8816,10 @@
           </a:solidFill>
           <a:ln/>
         </p:spPr>
+        <p:txBody>
+          <a:bodyPr/>
+          <a:p/>
+        </p:txBody>
       </p:sp>
       <p:sp>
         <p:nvSpPr>
@@ -8795,6 +8888,10 @@
             </a:outerShdw>
           </a:effectLst>
         </p:spPr>
+        <p:txBody>
+          <a:bodyPr/>
+          <a:p/>
+        </p:txBody>
       </p:sp>
       <p:sp>
         <p:nvSpPr>
@@ -8815,6 +8912,10 @@
           </a:solidFill>
           <a:ln/>
         </p:spPr>
+        <p:txBody>
+          <a:bodyPr/>
+          <a:p/>
+        </p:txBody>
       </p:sp>
       <p:sp>
         <p:nvSpPr>
@@ -8927,7 +9028,7 @@
                 <a:ea typeface="Calibri" pitchFamily="34" charset="-122"/>
                 <a:cs typeface="Calibri" pitchFamily="34" charset="-120"/>
               </a:rPr>
-              <a:t>Semantic Scholar API retrieves top-5 papers</a:t>
+              <a:t>3 APIs queried in parallel — up to 30 candidates fetched</a:t>
             </a:r>
             <a:endParaRPr lang="en-US" sz="1200" dirty="0"/>
           </a:p>
@@ -8961,6 +9062,10 @@
             </a:outerShdw>
           </a:effectLst>
         </p:spPr>
+        <p:txBody>
+          <a:bodyPr/>
+          <a:p/>
+        </p:txBody>
       </p:sp>
       <p:sp>
         <p:nvSpPr>
@@ -8981,6 +9086,10 @@
           </a:solidFill>
           <a:ln/>
         </p:spPr>
+        <p:txBody>
+          <a:bodyPr/>
+          <a:p/>
+        </p:txBody>
       </p:sp>
       <p:sp>
         <p:nvSpPr>
@@ -9127,6 +9236,10 @@
             </a:outerShdw>
           </a:effectLst>
         </p:spPr>
+        <p:txBody>
+          <a:bodyPr/>
+          <a:p/>
+        </p:txBody>
       </p:sp>
       <p:sp>
         <p:nvSpPr>
@@ -9147,6 +9260,10 @@
           </a:solidFill>
           <a:ln/>
         </p:spPr>
+        <p:txBody>
+          <a:bodyPr/>
+          <a:p/>
+        </p:txBody>
       </p:sp>
       <p:sp>
         <p:nvSpPr>
@@ -9293,6 +9410,10 @@
             </a:outerShdw>
           </a:effectLst>
         </p:spPr>
+        <p:txBody>
+          <a:bodyPr/>
+          <a:p/>
+        </p:txBody>
       </p:sp>
       <p:sp>
         <p:nvSpPr>
@@ -9313,6 +9434,10 @@
           </a:solidFill>
           <a:ln/>
         </p:spPr>
+        <p:txBody>
+          <a:bodyPr/>
+          <a:p/>
+        </p:txBody>
       </p:sp>
       <p:sp>
         <p:nvSpPr>
@@ -9425,7 +9550,7 @@
                 <a:ea typeface="Calibri" pitchFamily="34" charset="-122"/>
                 <a:cs typeface="Calibri" pitchFamily="34" charset="-120"/>
               </a:rPr>
-              <a:t>Cosine similarity ≥ 0.35 = verified citation</a:t>
+              <a:t>NLI 4-class scoring: Supported / Partial / Low Conf. / Unverified</a:t>
             </a:r>
             <a:endParaRPr lang="en-US" sz="1200" dirty="0"/>
           </a:p>
@@ -9459,6 +9584,10 @@
             </a:outerShdw>
           </a:effectLst>
         </p:spPr>
+        <p:txBody>
+          <a:bodyPr/>
+          <a:p/>
+        </p:txBody>
       </p:sp>
       <p:sp>
         <p:nvSpPr>
@@ -9479,6 +9608,10 @@
           </a:solidFill>
           <a:ln/>
         </p:spPr>
+        <p:txBody>
+          <a:bodyPr/>
+          <a:p/>
+        </p:txBody>
       </p:sp>
       <p:sp>
         <p:nvSpPr>
@@ -9625,6 +9758,10 @@
             </a:outerShdw>
           </a:effectLst>
         </p:spPr>
+        <p:txBody>
+          <a:bodyPr/>
+          <a:p/>
+        </p:txBody>
       </p:sp>
       <p:sp>
         <p:nvSpPr>
@@ -9645,6 +9782,10 @@
           </a:solidFill>
           <a:ln/>
         </p:spPr>
+        <p:txBody>
+          <a:bodyPr/>
+          <a:p/>
+        </p:txBody>
       </p:sp>
       <p:sp>
         <p:nvSpPr>

</xml_diff>